<commit_message>
docs: Add the repository URL to the GitHub slide
</commit_message>
<xml_diff>
--- a/Team24_CCSE0355_IntelligentMedicalInventoryTrackingSystem_Presentation.pptx
+++ b/Team24_CCSE0355_IntelligentMedicalInventoryTrackingSystem_Presentation.pptx
@@ -9720,7 +9720,7 @@
                 <a:latin typeface="Arial"/>
                 <a:ea typeface="Arial"/>
               </a:rPr>
-              <a:t>Source bundle in this submission</a:t>
+              <a:t>Source tree matches the repository</a:t>
             </a:r>
           </a:p>
         </p:txBody>
@@ -9906,7 +9906,7 @@
                 <a:latin typeface="Arial"/>
                 <a:ea typeface="Arial"/>
               </a:rPr>
-              <a:t>The complete buildable project travels with the submission.</a:t>
+              <a:t>Every file shown here is also published on GitHub.</a:t>
             </a:r>
           </a:p>
         </p:txBody>
@@ -10296,8 +10296,8 @@
         </p:nvSpPr>
         <p:spPr>
           <a:xfrm>
-            <a:off x="7429500" y="4343400"/>
-            <a:ext cx="4000500" cy="209550"/>
+            <a:off x="7429500" y="4305300"/>
+            <a:ext cx="4000500" cy="190500"/>
           </a:xfrm>
         </p:spPr>
         <p:txBody>
@@ -10313,34 +10313,77 @@
               </a:spcAft>
             </a:pPr>
             <a:r>
-              <a:rPr sz="1250" b="1">
+              <a:rPr sz="1200" b="1">
+                <a:solidFill>
+                  <a:srgbClr val="9CC3E8"/>
+                </a:solidFill>
+                <a:latin typeface="Arial"/>
+                <a:ea typeface="Arial"/>
+              </a:rPr>
+              <a:t>Repository URL</a:t>
+            </a:r>
+          </a:p>
+        </p:txBody>
+      </p:sp>
+      <p:sp>
+        <p:nvSpPr>
+          <p:cNvPr id="23" name="TextBox 23">
+            <a:extLst>
+              <a:ext uri="{FF2B5EF4-FFF2-40B4-BE49-F238E27FC236}">
+                <a16:creationId xmlns:a16="http://schemas.microsoft.com/office/drawing/2014/main" id="{9748F79F-4162-49CA-9106-9C6AB82666C5}"/>
+              </a:ext>
+            </a:extLst>
+          </p:cNvPr>
+          <p:cNvSpPr txBox="1"/>
+          <p:nvPr/>
+        </p:nvSpPr>
+        <p:spPr>
+          <a:xfrm>
+            <a:off x="7429500" y="4514850"/>
+            <a:ext cx="4000500" cy="609600"/>
+          </a:xfrm>
+        </p:spPr>
+        <p:txBody>
+          <a:bodyPr wrap="square" rtlCol="0" lIns="0" tIns="0" rIns="0" bIns="0" anchor="t"/>
+          <a:lstStyle/>
+          <a:p>
+            <a:pPr algn="l">
+              <a:lnSpc>
+                <a:spcPct val="105000"/>
+              </a:lnSpc>
+              <a:spcAft>
+                <a:spcPts val="0"/>
+              </a:spcAft>
+            </a:pPr>
+            <a:r>
+              <a:rPr b="1" sz="1200">
                 <a:solidFill>
                   <a:srgbClr val="FFFFFF"/>
                 </a:solidFill>
                 <a:latin typeface="Arial"/>
                 <a:ea typeface="Arial"/>
               </a:rPr>
-              <a:t>Repository status</a:t>
-            </a:r>
-          </a:p>
-        </p:txBody>
-      </p:sp>
-      <p:sp>
-        <p:nvSpPr>
-          <p:cNvPr id="23" name="TextBox 23">
-            <a:extLst>
-              <a:ext uri="{FF2B5EF4-FFF2-40B4-BE49-F238E27FC236}">
-                <a16:creationId xmlns:a16="http://schemas.microsoft.com/office/drawing/2014/main" id="{9748F79F-4162-49CA-9106-9C6AB82666C5}"/>
-              </a:ext>
-            </a:extLst>
-          </p:cNvPr>
-          <p:cNvSpPr txBox="1"/>
-          <p:nvPr/>
-        </p:nvSpPr>
-        <p:spPr>
-          <a:xfrm>
-            <a:off x="7429500" y="4610100"/>
-            <a:ext cx="4000500" cy="666750"/>
+              <a:t>https://github.com/DevvTrip/Intelligent-Medical-Inventory-Tracking-System</a:t>
+            </a:r>
+          </a:p>
+        </p:txBody>
+      </p:sp>
+      <p:sp>
+        <p:nvSpPr>
+          <p:cNvPr id="24" name="TextBox 24">
+            <a:extLst>
+              <a:ext uri="{FF2B5EF4-FFF2-40B4-BE49-F238E27FC236}">
+                <a16:creationId xmlns:a16="http://schemas.microsoft.com/office/drawing/2014/main" id="{04AE5CCC-CE7F-43B7-93DF-D7AF51845C7A}"/>
+              </a:ext>
+            </a:extLst>
+          </p:cNvPr>
+          <p:cNvSpPr txBox="1"/>
+          <p:nvPr/>
+        </p:nvSpPr>
+        <p:spPr>
+          <a:xfrm>
+            <a:off x="7429500" y="5181600"/>
+            <a:ext cx="4000500" cy="533400"/>
           </a:xfrm>
         </p:spPr>
         <p:txBody>
@@ -10349,64 +10392,21 @@
           <a:p>
             <a:pPr algn="l">
               <a:lnSpc>
-                <a:spcPct val="105000"/>
-              </a:lnSpc>
-              <a:spcAft>
-                <a:spcPts val="0"/>
-              </a:spcAft>
-            </a:pPr>
-            <a:r>
-              <a:rPr sz="1250">
-                <a:solidFill>
-                  <a:srgbClr val="E5E7EB"/>
-                </a:solidFill>
-                <a:latin typeface="Arial"/>
-                <a:ea typeface="Arial"/>
-              </a:rPr>
-              <a:t>No public GitHub remote is configured in this project bundle.</a:t>
-            </a:r>
-          </a:p>
-        </p:txBody>
-      </p:sp>
-      <p:sp>
-        <p:nvSpPr>
-          <p:cNvPr id="24" name="TextBox 24">
-            <a:extLst>
-              <a:ext uri="{FF2B5EF4-FFF2-40B4-BE49-F238E27FC236}">
-                <a16:creationId xmlns:a16="http://schemas.microsoft.com/office/drawing/2014/main" id="{04AE5CCC-CE7F-43B7-93DF-D7AF51845C7A}"/>
-              </a:ext>
-            </a:extLst>
-          </p:cNvPr>
-          <p:cNvSpPr txBox="1"/>
-          <p:nvPr/>
-        </p:nvSpPr>
-        <p:spPr>
-          <a:xfrm>
-            <a:off x="7429500" y="5334000"/>
-            <a:ext cx="4000500" cy="342900"/>
-          </a:xfrm>
-        </p:spPr>
-        <p:txBody>
-          <a:bodyPr wrap="square" rtlCol="0" lIns="0" tIns="0" rIns="0" bIns="0" anchor="t"/>
-          <a:lstStyle/>
-          <a:p>
-            <a:pPr algn="l">
-              <a:lnSpc>
-                <a:spcPct val="100000"/>
-              </a:lnSpc>
-              <a:spcAft>
-                <a:spcPts val="0"/>
-              </a:spcAft>
-            </a:pPr>
-            <a:r>
-              <a:rPr sz="1150">
+                <a:spcPct val="100000"/>
+              </a:lnSpc>
+              <a:spcAft>
+                <a:spcPts val="0"/>
+              </a:spcAft>
+            </a:pPr>
+            <a:r>
+              <a:rPr sz="1100">
                 <a:solidFill>
                   <a:srgbClr val="9CA3AF"/>
                 </a:solidFill>
                 <a:latin typeface="Arial"/>
                 <a:ea typeface="Arial"/>
               </a:rPr>
-              <a:t>All source and data are available for review.</a:t>
+              <a:t>Public repository, main branch: source, data, report and slides.</a:t>
             </a:r>
           </a:p>
         </p:txBody>

</xml_diff>